<commit_message>
docs(arch): wrap comparison diagrams so chip labels stay readable
Split-panel slides now use a two-row chip grid instead of five cramped
boxes, and the sparsest Q&A slides get a second spoken line.

Co-authored-by: Prex1228 <praveen2025work@users.noreply.github.com>
</commit_message>
<xml_diff>
--- a/docs/design/arch-qa-deck.pptx
+++ b/docs/design/arch-qa-deck.pptx
@@ -3780,8 +3780,8 @@
         </p:nvSpPr>
         <p:spPr>
           <a:xfrm>
-            <a:off x="502920" y="2980944"/>
-            <a:ext cx="11247120" cy="3438144"/>
+            <a:off x="502920" y="2962656"/>
+            <a:ext cx="11247120" cy="3456432"/>
           </a:xfrm>
           <a:prstGeom prst="rect">
             <a:avLst/>
@@ -4111,7 +4111,7 @@
         <p:spPr>
           <a:xfrm>
             <a:off x="502920" y="1700784"/>
-            <a:ext cx="5431536" cy="1170432"/>
+            <a:ext cx="5431536" cy="1572768"/>
           </a:xfrm>
           <a:prstGeom prst="roundRect">
             <a:avLst/>
@@ -4156,7 +4156,7 @@
         <p:spPr>
           <a:xfrm>
             <a:off x="612648" y="1755648"/>
-            <a:ext cx="5212080" cy="256032"/>
+            <a:ext cx="5212080" cy="237744"/>
           </a:xfrm>
           <a:prstGeom prst="rect">
             <a:avLst/>
@@ -4189,8 +4189,8 @@
         </p:nvSpPr>
         <p:spPr>
           <a:xfrm>
-            <a:off x="594360" y="2048256"/>
-            <a:ext cx="1257300" cy="731520"/>
+            <a:off x="594360" y="2011680"/>
+            <a:ext cx="2587752" cy="566928"/>
           </a:xfrm>
           <a:prstGeom prst="roundRect">
             <a:avLst/>
@@ -4250,8 +4250,8 @@
         </p:nvSpPr>
         <p:spPr>
           <a:xfrm>
-            <a:off x="1924812" y="2048256"/>
-            <a:ext cx="1257300" cy="731520"/>
+            <a:off x="3255264" y="2011680"/>
+            <a:ext cx="2587752" cy="566928"/>
           </a:xfrm>
           <a:prstGeom prst="roundRect">
             <a:avLst/>
@@ -4311,8 +4311,8 @@
         </p:nvSpPr>
         <p:spPr>
           <a:xfrm>
-            <a:off x="3255264" y="2048256"/>
-            <a:ext cx="1257300" cy="731520"/>
+            <a:off x="594360" y="2651760"/>
+            <a:ext cx="2587752" cy="566928"/>
           </a:xfrm>
           <a:prstGeom prst="roundRect">
             <a:avLst/>
@@ -4372,8 +4372,8 @@
         </p:nvSpPr>
         <p:spPr>
           <a:xfrm>
-            <a:off x="4585716" y="2048256"/>
-            <a:ext cx="1257300" cy="731520"/>
+            <a:off x="3255264" y="2651760"/>
+            <a:ext cx="2587752" cy="566928"/>
           </a:xfrm>
           <a:prstGeom prst="roundRect">
             <a:avLst/>
@@ -4433,7 +4433,7 @@
         </p:nvSpPr>
         <p:spPr>
           <a:xfrm>
-            <a:off x="5934456" y="2090928"/>
+            <a:off x="5934456" y="2225040"/>
             <a:ext cx="384048" cy="365760"/>
           </a:xfrm>
           <a:prstGeom prst="rect">
@@ -4469,7 +4469,7 @@
         <p:spPr>
           <a:xfrm>
             <a:off x="6318504" y="1700784"/>
-            <a:ext cx="5431536" cy="1170432"/>
+            <a:ext cx="5431536" cy="1572768"/>
           </a:xfrm>
           <a:prstGeom prst="roundRect">
             <a:avLst/>
@@ -4514,7 +4514,7 @@
         <p:spPr>
           <a:xfrm>
             <a:off x="6428232" y="1755648"/>
-            <a:ext cx="5212080" cy="256032"/>
+            <a:ext cx="5212080" cy="237744"/>
           </a:xfrm>
           <a:prstGeom prst="rect">
             <a:avLst/>
@@ -4547,8 +4547,8 @@
         </p:nvSpPr>
         <p:spPr>
           <a:xfrm>
-            <a:off x="6409944" y="2048256"/>
-            <a:ext cx="1257300" cy="731520"/>
+            <a:off x="6409944" y="2011680"/>
+            <a:ext cx="2587752" cy="566928"/>
           </a:xfrm>
           <a:prstGeom prst="roundRect">
             <a:avLst/>
@@ -4608,8 +4608,8 @@
         </p:nvSpPr>
         <p:spPr>
           <a:xfrm>
-            <a:off x="7740396" y="2048256"/>
-            <a:ext cx="1257300" cy="731520"/>
+            <a:off x="9070848" y="2011680"/>
+            <a:ext cx="2587752" cy="566928"/>
           </a:xfrm>
           <a:prstGeom prst="roundRect">
             <a:avLst/>
@@ -4669,8 +4669,8 @@
         </p:nvSpPr>
         <p:spPr>
           <a:xfrm>
-            <a:off x="9070848" y="2048256"/>
-            <a:ext cx="1257300" cy="731520"/>
+            <a:off x="6409944" y="2651760"/>
+            <a:ext cx="2587752" cy="566928"/>
           </a:xfrm>
           <a:prstGeom prst="roundRect">
             <a:avLst/>
@@ -4730,8 +4730,8 @@
         </p:nvSpPr>
         <p:spPr>
           <a:xfrm>
-            <a:off x="10401300" y="2048256"/>
-            <a:ext cx="1257300" cy="731520"/>
+            <a:off x="9070848" y="2651760"/>
+            <a:ext cx="2587752" cy="566928"/>
           </a:xfrm>
           <a:prstGeom prst="roundRect">
             <a:avLst/>
@@ -4791,8 +4791,8 @@
         </p:nvSpPr>
         <p:spPr>
           <a:xfrm>
-            <a:off x="502920" y="2980944"/>
-            <a:ext cx="11247120" cy="3438144"/>
+            <a:off x="502920" y="3364992"/>
+            <a:ext cx="11247120" cy="3054096"/>
           </a:xfrm>
           <a:prstGeom prst="rect">
             <a:avLst/>
@@ -5584,8 +5584,8 @@
         </p:nvSpPr>
         <p:spPr>
           <a:xfrm>
-            <a:off x="502920" y="2980944"/>
-            <a:ext cx="11247120" cy="3438144"/>
+            <a:off x="502920" y="2962656"/>
+            <a:ext cx="11247120" cy="3456432"/>
           </a:xfrm>
           <a:prstGeom prst="rect">
             <a:avLst/>
@@ -6489,8 +6489,8 @@
         </p:nvSpPr>
         <p:spPr>
           <a:xfrm>
-            <a:off x="502920" y="2980944"/>
-            <a:ext cx="11247120" cy="3438144"/>
+            <a:off x="502920" y="2962656"/>
+            <a:ext cx="11247120" cy="3456432"/>
           </a:xfrm>
           <a:prstGeom prst="rect">
             <a:avLst/>
@@ -6804,7 +6804,7 @@
         <p:spPr>
           <a:xfrm>
             <a:off x="502920" y="1700784"/>
-            <a:ext cx="5431536" cy="1170432"/>
+            <a:ext cx="5431536" cy="1572768"/>
           </a:xfrm>
           <a:prstGeom prst="roundRect">
             <a:avLst/>
@@ -6849,7 +6849,7 @@
         <p:spPr>
           <a:xfrm>
             <a:off x="612648" y="1755648"/>
-            <a:ext cx="5212080" cy="256032"/>
+            <a:ext cx="5212080" cy="237744"/>
           </a:xfrm>
           <a:prstGeom prst="rect">
             <a:avLst/>
@@ -6882,8 +6882,8 @@
         </p:nvSpPr>
         <p:spPr>
           <a:xfrm>
-            <a:off x="594360" y="2048256"/>
-            <a:ext cx="1257300" cy="731520"/>
+            <a:off x="594360" y="2011680"/>
+            <a:ext cx="2587752" cy="566928"/>
           </a:xfrm>
           <a:prstGeom prst="roundRect">
             <a:avLst/>
@@ -6943,8 +6943,8 @@
         </p:nvSpPr>
         <p:spPr>
           <a:xfrm>
-            <a:off x="1924812" y="2048256"/>
-            <a:ext cx="1257300" cy="731520"/>
+            <a:off x="3255264" y="2011680"/>
+            <a:ext cx="2587752" cy="566928"/>
           </a:xfrm>
           <a:prstGeom prst="roundRect">
             <a:avLst/>
@@ -7004,8 +7004,8 @@
         </p:nvSpPr>
         <p:spPr>
           <a:xfrm>
-            <a:off x="3255264" y="2048256"/>
-            <a:ext cx="1257300" cy="731520"/>
+            <a:off x="594360" y="2651760"/>
+            <a:ext cx="2587752" cy="566928"/>
           </a:xfrm>
           <a:prstGeom prst="roundRect">
             <a:avLst/>
@@ -7065,8 +7065,8 @@
         </p:nvSpPr>
         <p:spPr>
           <a:xfrm>
-            <a:off x="4585716" y="2048256"/>
-            <a:ext cx="1257300" cy="731520"/>
+            <a:off x="3255264" y="2651760"/>
+            <a:ext cx="2587752" cy="566928"/>
           </a:xfrm>
           <a:prstGeom prst="roundRect">
             <a:avLst/>
@@ -7126,7 +7126,7 @@
         </p:nvSpPr>
         <p:spPr>
           <a:xfrm>
-            <a:off x="5934456" y="2090928"/>
+            <a:off x="5934456" y="2225040"/>
             <a:ext cx="384048" cy="365760"/>
           </a:xfrm>
           <a:prstGeom prst="rect">
@@ -7162,7 +7162,7 @@
         <p:spPr>
           <a:xfrm>
             <a:off x="6318504" y="1700784"/>
-            <a:ext cx="5431536" cy="1170432"/>
+            <a:ext cx="5431536" cy="1572768"/>
           </a:xfrm>
           <a:prstGeom prst="roundRect">
             <a:avLst/>
@@ -7207,7 +7207,7 @@
         <p:spPr>
           <a:xfrm>
             <a:off x="6428232" y="1755648"/>
-            <a:ext cx="5212080" cy="256032"/>
+            <a:ext cx="5212080" cy="237744"/>
           </a:xfrm>
           <a:prstGeom prst="rect">
             <a:avLst/>
@@ -7240,8 +7240,8 @@
         </p:nvSpPr>
         <p:spPr>
           <a:xfrm>
-            <a:off x="6409944" y="2048256"/>
-            <a:ext cx="1257300" cy="731520"/>
+            <a:off x="6409944" y="2011680"/>
+            <a:ext cx="2587752" cy="566928"/>
           </a:xfrm>
           <a:prstGeom prst="roundRect">
             <a:avLst/>
@@ -7301,8 +7301,8 @@
         </p:nvSpPr>
         <p:spPr>
           <a:xfrm>
-            <a:off x="7740396" y="2048256"/>
-            <a:ext cx="1257300" cy="731520"/>
+            <a:off x="9070848" y="2011680"/>
+            <a:ext cx="2587752" cy="566928"/>
           </a:xfrm>
           <a:prstGeom prst="roundRect">
             <a:avLst/>
@@ -7362,8 +7362,8 @@
         </p:nvSpPr>
         <p:spPr>
           <a:xfrm>
-            <a:off x="9070848" y="2048256"/>
-            <a:ext cx="1257300" cy="731520"/>
+            <a:off x="6409944" y="2651760"/>
+            <a:ext cx="2587752" cy="566928"/>
           </a:xfrm>
           <a:prstGeom prst="roundRect">
             <a:avLst/>
@@ -7423,8 +7423,8 @@
         </p:nvSpPr>
         <p:spPr>
           <a:xfrm>
-            <a:off x="10401300" y="2048256"/>
-            <a:ext cx="1257300" cy="731520"/>
+            <a:off x="9070848" y="2651760"/>
+            <a:ext cx="2587752" cy="566928"/>
           </a:xfrm>
           <a:prstGeom prst="roundRect">
             <a:avLst/>
@@ -7484,8 +7484,8 @@
         </p:nvSpPr>
         <p:spPr>
           <a:xfrm>
-            <a:off x="502920" y="2980944"/>
-            <a:ext cx="11247120" cy="3438144"/>
+            <a:off x="502920" y="3364992"/>
+            <a:ext cx="11247120" cy="3054096"/>
           </a:xfrm>
           <a:prstGeom prst="rect">
             <a:avLst/>
@@ -7799,7 +7799,7 @@
         <p:spPr>
           <a:xfrm>
             <a:off x="502920" y="1700784"/>
-            <a:ext cx="5431536" cy="1170432"/>
+            <a:ext cx="5431536" cy="1572768"/>
           </a:xfrm>
           <a:prstGeom prst="roundRect">
             <a:avLst/>
@@ -7844,7 +7844,7 @@
         <p:spPr>
           <a:xfrm>
             <a:off x="612648" y="1755648"/>
-            <a:ext cx="5212080" cy="256032"/>
+            <a:ext cx="5212080" cy="237744"/>
           </a:xfrm>
           <a:prstGeom prst="rect">
             <a:avLst/>
@@ -7877,8 +7877,8 @@
         </p:nvSpPr>
         <p:spPr>
           <a:xfrm>
-            <a:off x="594360" y="2048256"/>
-            <a:ext cx="1257300" cy="731520"/>
+            <a:off x="594360" y="2011680"/>
+            <a:ext cx="2587752" cy="566928"/>
           </a:xfrm>
           <a:prstGeom prst="roundRect">
             <a:avLst/>
@@ -7938,8 +7938,8 @@
         </p:nvSpPr>
         <p:spPr>
           <a:xfrm>
-            <a:off x="1924812" y="2048256"/>
-            <a:ext cx="1257300" cy="731520"/>
+            <a:off x="3255264" y="2011680"/>
+            <a:ext cx="2587752" cy="566928"/>
           </a:xfrm>
           <a:prstGeom prst="roundRect">
             <a:avLst/>
@@ -7999,8 +7999,8 @@
         </p:nvSpPr>
         <p:spPr>
           <a:xfrm>
-            <a:off x="3255264" y="2048256"/>
-            <a:ext cx="1257300" cy="731520"/>
+            <a:off x="594360" y="2651760"/>
+            <a:ext cx="2587752" cy="566928"/>
           </a:xfrm>
           <a:prstGeom prst="roundRect">
             <a:avLst/>
@@ -8060,8 +8060,8 @@
         </p:nvSpPr>
         <p:spPr>
           <a:xfrm>
-            <a:off x="4585716" y="2048256"/>
-            <a:ext cx="1257300" cy="731520"/>
+            <a:off x="3255264" y="2651760"/>
+            <a:ext cx="2587752" cy="566928"/>
           </a:xfrm>
           <a:prstGeom prst="roundRect">
             <a:avLst/>
@@ -8121,7 +8121,7 @@
         </p:nvSpPr>
         <p:spPr>
           <a:xfrm>
-            <a:off x="5934456" y="2090928"/>
+            <a:off x="5934456" y="2225040"/>
             <a:ext cx="384048" cy="365760"/>
           </a:xfrm>
           <a:prstGeom prst="rect">
@@ -8157,7 +8157,7 @@
         <p:spPr>
           <a:xfrm>
             <a:off x="6318504" y="1700784"/>
-            <a:ext cx="5431536" cy="1170432"/>
+            <a:ext cx="5431536" cy="1572768"/>
           </a:xfrm>
           <a:prstGeom prst="roundRect">
             <a:avLst/>
@@ -8202,7 +8202,7 @@
         <p:spPr>
           <a:xfrm>
             <a:off x="6428232" y="1755648"/>
-            <a:ext cx="5212080" cy="256032"/>
+            <a:ext cx="5212080" cy="237744"/>
           </a:xfrm>
           <a:prstGeom prst="rect">
             <a:avLst/>
@@ -8235,8 +8235,8 @@
         </p:nvSpPr>
         <p:spPr>
           <a:xfrm>
-            <a:off x="6409944" y="2048256"/>
-            <a:ext cx="1257300" cy="731520"/>
+            <a:off x="6409944" y="2011680"/>
+            <a:ext cx="2587752" cy="566928"/>
           </a:xfrm>
           <a:prstGeom prst="roundRect">
             <a:avLst/>
@@ -8296,8 +8296,8 @@
         </p:nvSpPr>
         <p:spPr>
           <a:xfrm>
-            <a:off x="7740396" y="2048256"/>
-            <a:ext cx="1257300" cy="731520"/>
+            <a:off x="9070848" y="2011680"/>
+            <a:ext cx="2587752" cy="566928"/>
           </a:xfrm>
           <a:prstGeom prst="roundRect">
             <a:avLst/>
@@ -8357,8 +8357,8 @@
         </p:nvSpPr>
         <p:spPr>
           <a:xfrm>
-            <a:off x="9070848" y="2048256"/>
-            <a:ext cx="1257300" cy="731520"/>
+            <a:off x="6409944" y="2651760"/>
+            <a:ext cx="2587752" cy="566928"/>
           </a:xfrm>
           <a:prstGeom prst="roundRect">
             <a:avLst/>
@@ -8418,8 +8418,8 @@
         </p:nvSpPr>
         <p:spPr>
           <a:xfrm>
-            <a:off x="10401300" y="2048256"/>
-            <a:ext cx="1257300" cy="731520"/>
+            <a:off x="9070848" y="2651760"/>
+            <a:ext cx="2587752" cy="566928"/>
           </a:xfrm>
           <a:prstGeom prst="roundRect">
             <a:avLst/>
@@ -8479,8 +8479,8 @@
         </p:nvSpPr>
         <p:spPr>
           <a:xfrm>
-            <a:off x="502920" y="2980944"/>
-            <a:ext cx="11247120" cy="3438144"/>
+            <a:off x="502920" y="3364992"/>
+            <a:ext cx="11247120" cy="3054096"/>
           </a:xfrm>
           <a:prstGeom prst="rect">
             <a:avLst/>
@@ -9263,8 +9263,8 @@
         </p:nvSpPr>
         <p:spPr>
           <a:xfrm>
-            <a:off x="502920" y="2980944"/>
-            <a:ext cx="11247120" cy="3438144"/>
+            <a:off x="502920" y="2962656"/>
+            <a:ext cx="11247120" cy="3456432"/>
           </a:xfrm>
           <a:prstGeom prst="rect">
             <a:avLst/>
@@ -10012,8 +10012,8 @@
         </p:nvSpPr>
         <p:spPr>
           <a:xfrm>
-            <a:off x="502920" y="2980944"/>
-            <a:ext cx="11247120" cy="3438144"/>
+            <a:off x="502920" y="2962656"/>
+            <a:ext cx="11247120" cy="3456432"/>
           </a:xfrm>
           <a:prstGeom prst="rect">
             <a:avLst/>
@@ -10025,6 +10025,22 @@
             <a:spAutoFit/>
           </a:bodyPr>
           <a:lstStyle/>
+          <a:p>
+            <a:pPr>
+              <a:spcAft>
+                <a:spcPts val="800"/>
+              </a:spcAft>
+            </a:pPr>
+            <a:r>
+              <a:rPr sz="1600" b="0">
+                <a:solidFill>
+                  <a:srgbClr val="E6E8EE"/>
+                </a:solidFill>
+                <a:latin typeface="Calibri"/>
+              </a:rPr>
+              <a:t>▸  No Kafka / Solace brokers. No Motif books grid. No Helix recon clone. No CEES replacement.</a:t>
+            </a:r>
+          </a:p>
           <a:p>
             <a:pPr>
               <a:spcAft>
@@ -10901,8 +10917,8 @@
         </p:nvSpPr>
         <p:spPr>
           <a:xfrm>
-            <a:off x="502920" y="2980944"/>
-            <a:ext cx="11247120" cy="3438144"/>
+            <a:off x="502920" y="2962656"/>
+            <a:ext cx="11247120" cy="3456432"/>
           </a:xfrm>
           <a:prstGeom prst="rect">
             <a:avLst/>
@@ -10914,6 +10930,22 @@
             <a:spAutoFit/>
           </a:bodyPr>
           <a:lstStyle/>
+          <a:p>
+            <a:pPr>
+              <a:spcAft>
+                <a:spcPts val="800"/>
+              </a:spcAft>
+            </a:pPr>
+            <a:r>
+              <a:rPr sz="1600" b="0">
+                <a:solidFill>
+                  <a:srgbClr val="E6E8EE"/>
+                </a:solidFill>
+                <a:latin typeface="Calibri"/>
+              </a:rPr>
+              <a:t>▸  This hub is the only Ready / Blocked system of decision. First production outcome: FOBO.</a:t>
+            </a:r>
+          </a:p>
           <a:p>
             <a:pPr>
               <a:spcAft>
@@ -11598,8 +11630,8 @@
         </p:nvSpPr>
         <p:spPr>
           <a:xfrm>
-            <a:off x="502920" y="2980944"/>
-            <a:ext cx="11247120" cy="3438144"/>
+            <a:off x="502920" y="2962656"/>
+            <a:ext cx="11247120" cy="3456432"/>
           </a:xfrm>
           <a:prstGeom prst="rect">
             <a:avLst/>
@@ -12311,8 +12343,8 @@
         </p:nvSpPr>
         <p:spPr>
           <a:xfrm>
-            <a:off x="502920" y="2980944"/>
-            <a:ext cx="11247120" cy="3438144"/>
+            <a:off x="502920" y="2962656"/>
+            <a:ext cx="11247120" cy="3456432"/>
           </a:xfrm>
           <a:prstGeom prst="rect">
             <a:avLst/>
@@ -12642,7 +12674,7 @@
         <p:spPr>
           <a:xfrm>
             <a:off x="502920" y="1700784"/>
-            <a:ext cx="5431536" cy="1170432"/>
+            <a:ext cx="5431536" cy="1572768"/>
           </a:xfrm>
           <a:prstGeom prst="roundRect">
             <a:avLst/>
@@ -12687,7 +12719,7 @@
         <p:spPr>
           <a:xfrm>
             <a:off x="612648" y="1755648"/>
-            <a:ext cx="5212080" cy="256032"/>
+            <a:ext cx="5212080" cy="237744"/>
           </a:xfrm>
           <a:prstGeom prst="rect">
             <a:avLst/>
@@ -12720,8 +12752,8 @@
         </p:nvSpPr>
         <p:spPr>
           <a:xfrm>
-            <a:off x="594360" y="2048256"/>
-            <a:ext cx="991209" cy="731520"/>
+            <a:off x="594360" y="2011680"/>
+            <a:ext cx="1700784" cy="566928"/>
           </a:xfrm>
           <a:prstGeom prst="roundRect">
             <a:avLst/>
@@ -12781,8 +12813,8 @@
         </p:nvSpPr>
         <p:spPr>
           <a:xfrm>
-            <a:off x="1658721" y="2048256"/>
-            <a:ext cx="991209" cy="731520"/>
+            <a:off x="2368296" y="2011680"/>
+            <a:ext cx="1700784" cy="566928"/>
           </a:xfrm>
           <a:prstGeom prst="roundRect">
             <a:avLst/>
@@ -12842,8 +12874,8 @@
         </p:nvSpPr>
         <p:spPr>
           <a:xfrm>
-            <a:off x="2723083" y="2048256"/>
-            <a:ext cx="991209" cy="731520"/>
+            <a:off x="4142232" y="2011680"/>
+            <a:ext cx="1700784" cy="566928"/>
           </a:xfrm>
           <a:prstGeom prst="roundRect">
             <a:avLst/>
@@ -12903,8 +12935,8 @@
         </p:nvSpPr>
         <p:spPr>
           <a:xfrm>
-            <a:off x="3787444" y="2048256"/>
-            <a:ext cx="991209" cy="731520"/>
+            <a:off x="594360" y="2651760"/>
+            <a:ext cx="1700784" cy="566928"/>
           </a:xfrm>
           <a:prstGeom prst="roundRect">
             <a:avLst/>
@@ -12964,8 +12996,8 @@
         </p:nvSpPr>
         <p:spPr>
           <a:xfrm>
-            <a:off x="4851806" y="2048256"/>
-            <a:ext cx="991209" cy="731520"/>
+            <a:off x="2368296" y="2651760"/>
+            <a:ext cx="1700784" cy="566928"/>
           </a:xfrm>
           <a:prstGeom prst="roundRect">
             <a:avLst/>
@@ -13025,7 +13057,7 @@
         </p:nvSpPr>
         <p:spPr>
           <a:xfrm>
-            <a:off x="5934456" y="2090928"/>
+            <a:off x="5934456" y="2225040"/>
             <a:ext cx="384048" cy="365760"/>
           </a:xfrm>
           <a:prstGeom prst="rect">
@@ -13061,7 +13093,7 @@
         <p:spPr>
           <a:xfrm>
             <a:off x="6318504" y="1700784"/>
-            <a:ext cx="5431536" cy="1170432"/>
+            <a:ext cx="5431536" cy="1572768"/>
           </a:xfrm>
           <a:prstGeom prst="roundRect">
             <a:avLst/>
@@ -13106,7 +13138,7 @@
         <p:spPr>
           <a:xfrm>
             <a:off x="6428232" y="1755648"/>
-            <a:ext cx="5212080" cy="256032"/>
+            <a:ext cx="5212080" cy="237744"/>
           </a:xfrm>
           <a:prstGeom prst="rect">
             <a:avLst/>
@@ -13139,8 +13171,8 @@
         </p:nvSpPr>
         <p:spPr>
           <a:xfrm>
-            <a:off x="6409944" y="2048256"/>
-            <a:ext cx="1257300" cy="731520"/>
+            <a:off x="6409944" y="2011680"/>
+            <a:ext cx="2587752" cy="566928"/>
           </a:xfrm>
           <a:prstGeom prst="roundRect">
             <a:avLst/>
@@ -13200,8 +13232,8 @@
         </p:nvSpPr>
         <p:spPr>
           <a:xfrm>
-            <a:off x="7740396" y="2048256"/>
-            <a:ext cx="1257300" cy="731520"/>
+            <a:off x="9070848" y="2011680"/>
+            <a:ext cx="2587752" cy="566928"/>
           </a:xfrm>
           <a:prstGeom prst="roundRect">
             <a:avLst/>
@@ -13261,8 +13293,8 @@
         </p:nvSpPr>
         <p:spPr>
           <a:xfrm>
-            <a:off x="9070848" y="2048256"/>
-            <a:ext cx="1257300" cy="731520"/>
+            <a:off x="6409944" y="2651760"/>
+            <a:ext cx="2587752" cy="566928"/>
           </a:xfrm>
           <a:prstGeom prst="roundRect">
             <a:avLst/>
@@ -13322,8 +13354,8 @@
         </p:nvSpPr>
         <p:spPr>
           <a:xfrm>
-            <a:off x="10401300" y="2048256"/>
-            <a:ext cx="1257300" cy="731520"/>
+            <a:off x="9070848" y="2651760"/>
+            <a:ext cx="2587752" cy="566928"/>
           </a:xfrm>
           <a:prstGeom prst="roundRect">
             <a:avLst/>
@@ -13383,8 +13415,8 @@
         </p:nvSpPr>
         <p:spPr>
           <a:xfrm>
-            <a:off x="502920" y="2980944"/>
-            <a:ext cx="11247120" cy="3438144"/>
+            <a:off x="502920" y="3364992"/>
+            <a:ext cx="11247120" cy="3054096"/>
           </a:xfrm>
           <a:prstGeom prst="rect">
             <a:avLst/>
@@ -14176,7 +14208,7 @@
         </p:nvSpPr>
         <p:spPr>
           <a:xfrm>
-            <a:off x="502920" y="2980944"/>
+            <a:off x="502920" y="2962656"/>
             <a:ext cx="11247120" cy="868680"/>
           </a:xfrm>
           <a:prstGeom prst="roundRect">
@@ -14219,7 +14251,7 @@
         </p:nvSpPr>
         <p:spPr>
           <a:xfrm>
-            <a:off x="685800" y="3054096"/>
+            <a:off x="685800" y="3035808"/>
             <a:ext cx="10881360" cy="758952"/>
           </a:xfrm>
           <a:prstGeom prst="rect">
@@ -14264,7 +14296,7 @@
         </p:nvSpPr>
         <p:spPr>
           <a:xfrm>
-            <a:off x="502920" y="3941064"/>
+            <a:off x="502920" y="3922776"/>
             <a:ext cx="11247120" cy="868680"/>
           </a:xfrm>
           <a:prstGeom prst="roundRect">
@@ -14307,7 +14339,7 @@
         </p:nvSpPr>
         <p:spPr>
           <a:xfrm>
-            <a:off x="685800" y="4014216"/>
+            <a:off x="685800" y="3995928"/>
             <a:ext cx="10881360" cy="758952"/>
           </a:xfrm>
           <a:prstGeom prst="rect">
@@ -14628,7 +14660,7 @@
         <p:spPr>
           <a:xfrm>
             <a:off x="502920" y="1700784"/>
-            <a:ext cx="5431536" cy="1051560"/>
+            <a:ext cx="5431536" cy="1298448"/>
           </a:xfrm>
           <a:prstGeom prst="roundRect">
             <a:avLst/>
@@ -14673,7 +14705,7 @@
         <p:spPr>
           <a:xfrm>
             <a:off x="612648" y="1755648"/>
-            <a:ext cx="5212080" cy="256032"/>
+            <a:ext cx="5212080" cy="237744"/>
           </a:xfrm>
           <a:prstGeom prst="rect">
             <a:avLst/>
@@ -14706,8 +14738,8 @@
         </p:nvSpPr>
         <p:spPr>
           <a:xfrm>
-            <a:off x="594360" y="2048256"/>
-            <a:ext cx="1257300" cy="612648"/>
+            <a:off x="594360" y="2011680"/>
+            <a:ext cx="2587752" cy="429768"/>
           </a:xfrm>
           <a:prstGeom prst="roundRect">
             <a:avLst/>
@@ -14767,8 +14799,8 @@
         </p:nvSpPr>
         <p:spPr>
           <a:xfrm>
-            <a:off x="1924812" y="2048256"/>
-            <a:ext cx="1257300" cy="612648"/>
+            <a:off x="3255264" y="2011680"/>
+            <a:ext cx="2587752" cy="429768"/>
           </a:xfrm>
           <a:prstGeom prst="roundRect">
             <a:avLst/>
@@ -14828,8 +14860,8 @@
         </p:nvSpPr>
         <p:spPr>
           <a:xfrm>
-            <a:off x="3255264" y="2048256"/>
-            <a:ext cx="1257300" cy="612648"/>
+            <a:off x="594360" y="2514600"/>
+            <a:ext cx="2587752" cy="429768"/>
           </a:xfrm>
           <a:prstGeom prst="roundRect">
             <a:avLst/>
@@ -14889,8 +14921,8 @@
         </p:nvSpPr>
         <p:spPr>
           <a:xfrm>
-            <a:off x="4585716" y="2048256"/>
-            <a:ext cx="1257300" cy="612648"/>
+            <a:off x="3255264" y="2514600"/>
+            <a:ext cx="2587752" cy="429768"/>
           </a:xfrm>
           <a:prstGeom prst="roundRect">
             <a:avLst/>
@@ -14950,7 +14982,7 @@
         </p:nvSpPr>
         <p:spPr>
           <a:xfrm>
-            <a:off x="5934456" y="2051304"/>
+            <a:off x="5934456" y="2133600"/>
             <a:ext cx="384048" cy="365760"/>
           </a:xfrm>
           <a:prstGeom prst="rect">
@@ -14986,7 +15018,7 @@
         <p:spPr>
           <a:xfrm>
             <a:off x="6318504" y="1700784"/>
-            <a:ext cx="5431536" cy="1051560"/>
+            <a:ext cx="5431536" cy="1298448"/>
           </a:xfrm>
           <a:prstGeom prst="roundRect">
             <a:avLst/>
@@ -15031,7 +15063,7 @@
         <p:spPr>
           <a:xfrm>
             <a:off x="6428232" y="1755648"/>
-            <a:ext cx="5212080" cy="256032"/>
+            <a:ext cx="5212080" cy="237744"/>
           </a:xfrm>
           <a:prstGeom prst="rect">
             <a:avLst/>
@@ -15064,8 +15096,8 @@
         </p:nvSpPr>
         <p:spPr>
           <a:xfrm>
-            <a:off x="6409944" y="2048256"/>
-            <a:ext cx="1257300" cy="612648"/>
+            <a:off x="6409944" y="2011680"/>
+            <a:ext cx="2587752" cy="429768"/>
           </a:xfrm>
           <a:prstGeom prst="roundRect">
             <a:avLst/>
@@ -15125,8 +15157,8 @@
         </p:nvSpPr>
         <p:spPr>
           <a:xfrm>
-            <a:off x="7740396" y="2048256"/>
-            <a:ext cx="1257300" cy="612648"/>
+            <a:off x="9070848" y="2011680"/>
+            <a:ext cx="2587752" cy="429768"/>
           </a:xfrm>
           <a:prstGeom prst="roundRect">
             <a:avLst/>
@@ -15186,8 +15218,8 @@
         </p:nvSpPr>
         <p:spPr>
           <a:xfrm>
-            <a:off x="9070848" y="2048256"/>
-            <a:ext cx="1257300" cy="612648"/>
+            <a:off x="6409944" y="2514600"/>
+            <a:ext cx="2587752" cy="429768"/>
           </a:xfrm>
           <a:prstGeom prst="roundRect">
             <a:avLst/>
@@ -15247,8 +15279,8 @@
         </p:nvSpPr>
         <p:spPr>
           <a:xfrm>
-            <a:off x="10401300" y="2048256"/>
-            <a:ext cx="1257300" cy="612648"/>
+            <a:off x="9070848" y="2514600"/>
+            <a:ext cx="2587752" cy="429768"/>
           </a:xfrm>
           <a:prstGeom prst="roundRect">
             <a:avLst/>
@@ -15309,7 +15341,7 @@
           <p:nvPr/>
         </p:nvGraphicFramePr>
         <p:xfrm>
-          <a:off x="502920" y="2862072"/>
+          <a:off x="502920" y="3090672"/>
           <a:ext cx="11247120" cy="2084832"/>
         </p:xfrm>
         <a:graphic>
@@ -16497,8 +16529,8 @@
         </p:nvSpPr>
         <p:spPr>
           <a:xfrm>
-            <a:off x="502920" y="2980944"/>
-            <a:ext cx="11247120" cy="3438144"/>
+            <a:off x="502920" y="2962656"/>
+            <a:ext cx="11247120" cy="3456432"/>
           </a:xfrm>
           <a:prstGeom prst="rect">
             <a:avLst/>
@@ -16828,7 +16860,7 @@
         <p:spPr>
           <a:xfrm>
             <a:off x="502920" y="1700784"/>
-            <a:ext cx="5431536" cy="1170432"/>
+            <a:ext cx="5431536" cy="1572768"/>
           </a:xfrm>
           <a:prstGeom prst="roundRect">
             <a:avLst/>
@@ -16873,7 +16905,7 @@
         <p:spPr>
           <a:xfrm>
             <a:off x="612648" y="1755648"/>
-            <a:ext cx="5212080" cy="256032"/>
+            <a:ext cx="5212080" cy="237744"/>
           </a:xfrm>
           <a:prstGeom prst="rect">
             <a:avLst/>
@@ -16906,8 +16938,8 @@
         </p:nvSpPr>
         <p:spPr>
           <a:xfrm>
-            <a:off x="594360" y="2048256"/>
-            <a:ext cx="1257300" cy="731520"/>
+            <a:off x="594360" y="2011680"/>
+            <a:ext cx="2587752" cy="566928"/>
           </a:xfrm>
           <a:prstGeom prst="roundRect">
             <a:avLst/>
@@ -16967,8 +16999,8 @@
         </p:nvSpPr>
         <p:spPr>
           <a:xfrm>
-            <a:off x="1924812" y="2048256"/>
-            <a:ext cx="1257300" cy="731520"/>
+            <a:off x="3255264" y="2011680"/>
+            <a:ext cx="2587752" cy="566928"/>
           </a:xfrm>
           <a:prstGeom prst="roundRect">
             <a:avLst/>
@@ -17028,8 +17060,8 @@
         </p:nvSpPr>
         <p:spPr>
           <a:xfrm>
-            <a:off x="3255264" y="2048256"/>
-            <a:ext cx="1257300" cy="731520"/>
+            <a:off x="594360" y="2651760"/>
+            <a:ext cx="2587752" cy="566928"/>
           </a:xfrm>
           <a:prstGeom prst="roundRect">
             <a:avLst/>
@@ -17089,8 +17121,8 @@
         </p:nvSpPr>
         <p:spPr>
           <a:xfrm>
-            <a:off x="4585716" y="2048256"/>
-            <a:ext cx="1257300" cy="731520"/>
+            <a:off x="3255264" y="2651760"/>
+            <a:ext cx="2587752" cy="566928"/>
           </a:xfrm>
           <a:prstGeom prst="roundRect">
             <a:avLst/>
@@ -17150,7 +17182,7 @@
         </p:nvSpPr>
         <p:spPr>
           <a:xfrm>
-            <a:off x="5934456" y="2090928"/>
+            <a:off x="5934456" y="2225040"/>
             <a:ext cx="384048" cy="365760"/>
           </a:xfrm>
           <a:prstGeom prst="rect">
@@ -17186,7 +17218,7 @@
         <p:spPr>
           <a:xfrm>
             <a:off x="6318504" y="1700784"/>
-            <a:ext cx="5431536" cy="1170432"/>
+            <a:ext cx="5431536" cy="1572768"/>
           </a:xfrm>
           <a:prstGeom prst="roundRect">
             <a:avLst/>
@@ -17231,7 +17263,7 @@
         <p:spPr>
           <a:xfrm>
             <a:off x="6428232" y="1755648"/>
-            <a:ext cx="5212080" cy="256032"/>
+            <a:ext cx="5212080" cy="237744"/>
           </a:xfrm>
           <a:prstGeom prst="rect">
             <a:avLst/>
@@ -17264,8 +17296,8 @@
         </p:nvSpPr>
         <p:spPr>
           <a:xfrm>
-            <a:off x="6409944" y="2048256"/>
-            <a:ext cx="1257300" cy="731520"/>
+            <a:off x="6409944" y="2011680"/>
+            <a:ext cx="2587752" cy="566928"/>
           </a:xfrm>
           <a:prstGeom prst="roundRect">
             <a:avLst/>
@@ -17325,8 +17357,8 @@
         </p:nvSpPr>
         <p:spPr>
           <a:xfrm>
-            <a:off x="7740396" y="2048256"/>
-            <a:ext cx="1257300" cy="731520"/>
+            <a:off x="9070848" y="2011680"/>
+            <a:ext cx="2587752" cy="566928"/>
           </a:xfrm>
           <a:prstGeom prst="roundRect">
             <a:avLst/>
@@ -17386,8 +17418,8 @@
         </p:nvSpPr>
         <p:spPr>
           <a:xfrm>
-            <a:off x="9070848" y="2048256"/>
-            <a:ext cx="1257300" cy="731520"/>
+            <a:off x="6409944" y="2651760"/>
+            <a:ext cx="2587752" cy="566928"/>
           </a:xfrm>
           <a:prstGeom prst="roundRect">
             <a:avLst/>
@@ -17447,8 +17479,8 @@
         </p:nvSpPr>
         <p:spPr>
           <a:xfrm>
-            <a:off x="10401300" y="2048256"/>
-            <a:ext cx="1257300" cy="731520"/>
+            <a:off x="9070848" y="2651760"/>
+            <a:ext cx="2587752" cy="566928"/>
           </a:xfrm>
           <a:prstGeom prst="roundRect">
             <a:avLst/>
@@ -17508,8 +17540,8 @@
         </p:nvSpPr>
         <p:spPr>
           <a:xfrm>
-            <a:off x="502920" y="2980944"/>
-            <a:ext cx="11247120" cy="3438144"/>
+            <a:off x="502920" y="3364992"/>
+            <a:ext cx="11247120" cy="3054096"/>
           </a:xfrm>
           <a:prstGeom prst="rect">
             <a:avLst/>
@@ -17823,7 +17855,7 @@
         <p:spPr>
           <a:xfrm>
             <a:off x="502920" y="1700784"/>
-            <a:ext cx="5431536" cy="1170432"/>
+            <a:ext cx="5431536" cy="1572768"/>
           </a:xfrm>
           <a:prstGeom prst="roundRect">
             <a:avLst/>
@@ -17868,7 +17900,7 @@
         <p:spPr>
           <a:xfrm>
             <a:off x="612648" y="1755648"/>
-            <a:ext cx="5212080" cy="256032"/>
+            <a:ext cx="5212080" cy="237744"/>
           </a:xfrm>
           <a:prstGeom prst="rect">
             <a:avLst/>
@@ -17901,8 +17933,8 @@
         </p:nvSpPr>
         <p:spPr>
           <a:xfrm>
-            <a:off x="594360" y="2048256"/>
-            <a:ext cx="1700784" cy="731520"/>
+            <a:off x="594360" y="2011680"/>
+            <a:ext cx="1700784" cy="1207008"/>
           </a:xfrm>
           <a:prstGeom prst="roundRect">
             <a:avLst/>
@@ -17962,8 +17994,8 @@
         </p:nvSpPr>
         <p:spPr>
           <a:xfrm>
-            <a:off x="2368296" y="2048256"/>
-            <a:ext cx="1700784" cy="731520"/>
+            <a:off x="2368296" y="2011680"/>
+            <a:ext cx="1700784" cy="1207008"/>
           </a:xfrm>
           <a:prstGeom prst="roundRect">
             <a:avLst/>
@@ -18023,8 +18055,8 @@
         </p:nvSpPr>
         <p:spPr>
           <a:xfrm>
-            <a:off x="4142232" y="2048256"/>
-            <a:ext cx="1700784" cy="731520"/>
+            <a:off x="4142232" y="2011680"/>
+            <a:ext cx="1700784" cy="1207008"/>
           </a:xfrm>
           <a:prstGeom prst="roundRect">
             <a:avLst/>
@@ -18084,7 +18116,7 @@
         </p:nvSpPr>
         <p:spPr>
           <a:xfrm>
-            <a:off x="5934456" y="2090928"/>
+            <a:off x="5934456" y="2225040"/>
             <a:ext cx="384048" cy="365760"/>
           </a:xfrm>
           <a:prstGeom prst="rect">
@@ -18120,7 +18152,7 @@
         <p:spPr>
           <a:xfrm>
             <a:off x="6318504" y="1700784"/>
-            <a:ext cx="5431536" cy="1170432"/>
+            <a:ext cx="5431536" cy="1572768"/>
           </a:xfrm>
           <a:prstGeom prst="roundRect">
             <a:avLst/>
@@ -18165,7 +18197,7 @@
         <p:spPr>
           <a:xfrm>
             <a:off x="6428232" y="1755648"/>
-            <a:ext cx="5212080" cy="256032"/>
+            <a:ext cx="5212080" cy="237744"/>
           </a:xfrm>
           <a:prstGeom prst="rect">
             <a:avLst/>
@@ -18198,8 +18230,8 @@
         </p:nvSpPr>
         <p:spPr>
           <a:xfrm>
-            <a:off x="6409944" y="2048256"/>
-            <a:ext cx="1700784" cy="731520"/>
+            <a:off x="6409944" y="2011680"/>
+            <a:ext cx="1700784" cy="1207008"/>
           </a:xfrm>
           <a:prstGeom prst="roundRect">
             <a:avLst/>
@@ -18259,8 +18291,8 @@
         </p:nvSpPr>
         <p:spPr>
           <a:xfrm>
-            <a:off x="8183880" y="2048256"/>
-            <a:ext cx="1700784" cy="731520"/>
+            <a:off x="8183880" y="2011680"/>
+            <a:ext cx="1700784" cy="1207008"/>
           </a:xfrm>
           <a:prstGeom prst="roundRect">
             <a:avLst/>
@@ -18320,8 +18352,8 @@
         </p:nvSpPr>
         <p:spPr>
           <a:xfrm>
-            <a:off x="9957816" y="2048256"/>
-            <a:ext cx="1700784" cy="731520"/>
+            <a:off x="9957816" y="2011680"/>
+            <a:ext cx="1700784" cy="1207008"/>
           </a:xfrm>
           <a:prstGeom prst="roundRect">
             <a:avLst/>
@@ -18381,8 +18413,8 @@
         </p:nvSpPr>
         <p:spPr>
           <a:xfrm>
-            <a:off x="502920" y="2980944"/>
-            <a:ext cx="11247120" cy="3438144"/>
+            <a:off x="502920" y="3364992"/>
+            <a:ext cx="11247120" cy="3054096"/>
           </a:xfrm>
           <a:prstGeom prst="rect">
             <a:avLst/>
@@ -18394,6 +18426,22 @@
             <a:spAutoFit/>
           </a:bodyPr>
           <a:lstStyle/>
+          <a:p>
+            <a:pPr>
+              <a:spcAft>
+                <a:spcPts val="800"/>
+              </a:spcAft>
+            </a:pPr>
+            <a:r>
+              <a:rPr sz="1600" b="0">
+                <a:solidFill>
+                  <a:srgbClr val="E6E8EE"/>
+                </a:solidFill>
+                <a:latin typeface="Calibri"/>
+              </a:rPr>
+              <a:t>▸  Optional later: read-scale only. Never the system of decision.</a:t>
+            </a:r>
+          </a:p>
           <a:p>
             <a:pPr>
               <a:spcAft>
@@ -18730,7 +18778,7 @@
         <p:spPr>
           <a:xfrm>
             <a:off x="502920" y="1993392"/>
-            <a:ext cx="1956816" cy="722376"/>
+            <a:ext cx="1956816" cy="694944"/>
           </a:xfrm>
           <a:prstGeom prst="roundRect">
             <a:avLst/>
@@ -18791,7 +18839,7 @@
         <p:spPr>
           <a:xfrm>
             <a:off x="2514600" y="1993392"/>
-            <a:ext cx="256032" cy="722376"/>
+            <a:ext cx="256032" cy="694944"/>
           </a:xfrm>
           <a:prstGeom prst="rect">
             <a:avLst/>
@@ -18826,7 +18874,7 @@
         <p:spPr>
           <a:xfrm>
             <a:off x="2825496" y="1993392"/>
-            <a:ext cx="1956816" cy="722376"/>
+            <a:ext cx="1956816" cy="694944"/>
           </a:xfrm>
           <a:prstGeom prst="roundRect">
             <a:avLst/>
@@ -18887,7 +18935,7 @@
         <p:spPr>
           <a:xfrm>
             <a:off x="4837176" y="1993392"/>
-            <a:ext cx="256032" cy="722376"/>
+            <a:ext cx="256032" cy="694944"/>
           </a:xfrm>
           <a:prstGeom prst="rect">
             <a:avLst/>
@@ -18922,7 +18970,7 @@
         <p:spPr>
           <a:xfrm>
             <a:off x="5148072" y="1993392"/>
-            <a:ext cx="1956816" cy="722376"/>
+            <a:ext cx="1956816" cy="694944"/>
           </a:xfrm>
           <a:prstGeom prst="roundRect">
             <a:avLst/>
@@ -18983,7 +19031,7 @@
         <p:spPr>
           <a:xfrm>
             <a:off x="7159752" y="1993392"/>
-            <a:ext cx="256032" cy="722376"/>
+            <a:ext cx="256032" cy="694944"/>
           </a:xfrm>
           <a:prstGeom prst="rect">
             <a:avLst/>
@@ -19018,7 +19066,7 @@
         <p:spPr>
           <a:xfrm>
             <a:off x="7470648" y="1993392"/>
-            <a:ext cx="1956816" cy="722376"/>
+            <a:ext cx="1956816" cy="694944"/>
           </a:xfrm>
           <a:prstGeom prst="roundRect">
             <a:avLst/>
@@ -19079,7 +19127,7 @@
         <p:spPr>
           <a:xfrm>
             <a:off x="9482328" y="1993392"/>
-            <a:ext cx="256032" cy="722376"/>
+            <a:ext cx="256032" cy="694944"/>
           </a:xfrm>
           <a:prstGeom prst="rect">
             <a:avLst/>
@@ -19114,7 +19162,7 @@
         <p:spPr>
           <a:xfrm>
             <a:off x="9793224" y="1993392"/>
-            <a:ext cx="1956816" cy="722376"/>
+            <a:ext cx="1956816" cy="694944"/>
           </a:xfrm>
           <a:prstGeom prst="roundRect">
             <a:avLst/>
@@ -19175,7 +19223,7 @@
           <p:nvPr/>
         </p:nvGraphicFramePr>
         <p:xfrm>
-          <a:off x="502920" y="2862072"/>
+          <a:off x="502920" y="2816352"/>
           <a:ext cx="11247120" cy="2084832"/>
         </p:xfrm>
         <a:graphic>

</xml_diff>